<commit_message>
Remove presenter badge from header; rename skill to skt-ppt
</commit_message>
<xml_diff>
--- a/ppt/idea_pitch_template.pptx
+++ b/ppt/idea_pitch_template.pptx
@@ -3926,88 +3926,7 @@
       </p:cxnSp>
       <p:sp>
         <p:nvSpPr>
-          <p:cNvPr id="4" name="Rectangle 3"/>
-          <p:cNvSpPr/>
-          <p:nvPr/>
-        </p:nvSpPr>
-        <p:spPr>
-          <a:xfrm>
-            <a:off x="10058400" y="164592"/>
-            <a:ext cx="1737360" cy="603504"/>
-          </a:xfrm>
-          <a:prstGeom prst="rect">
-            <a:avLst/>
-          </a:prstGeom>
-          <a:solidFill>
-            <a:srgbClr val="1273C4"/>
-          </a:solidFill>
-          <a:ln>
-            <a:noFill/>
-          </a:ln>
-          <a:effectLst/>
-        </p:spPr>
-        <p:style>
-          <a:lnRef idx="1">
-            <a:schemeClr val="accent1"/>
-          </a:lnRef>
-          <a:fillRef idx="3">
-            <a:schemeClr val="accent1"/>
-          </a:fillRef>
-          <a:effectRef idx="2">
-            <a:schemeClr val="accent1"/>
-          </a:effectRef>
-          <a:fontRef idx="minor">
-            <a:schemeClr val="lt1"/>
-          </a:fontRef>
-        </p:style>
-        <p:txBody>
-          <a:bodyPr rtlCol="0" anchor="ctr" wrap="square" lIns="50800" rIns="50800" tIns="25400" bIns="25400"/>
-          <a:lstStyle/>
-          <a:p>
-            <a:pPr algn="ctr">
-              <a:spcBef>
-                <a:spcPts val="0"/>
-              </a:spcBef>
-              <a:spcAft>
-                <a:spcPts val="0"/>
-              </a:spcAft>
-            </a:pPr>
-            <a:r>
-              <a:rPr sz="1400" b="0">
-                <a:solidFill>
-                  <a:srgbClr val="FFFFFF"/>
-                </a:solidFill>
-                <a:latin typeface="NanumSquareOTF_ac ExtraBold"/>
-                <a:ea typeface="NanumSquareOTF_ac ExtraBold"/>
-              </a:rPr>
-              <a:t>발표자</a:t>
-            </a:r>
-          </a:p>
-          <a:p>
-            <a:pPr algn="ctr">
-              <a:spcBef>
-                <a:spcPts val="0"/>
-              </a:spcBef>
-              <a:spcAft>
-                <a:spcPts val="0"/>
-              </a:spcAft>
-            </a:pPr>
-            <a:r>
-              <a:rPr sz="1000" b="0">
-                <a:solidFill>
-                  <a:srgbClr val="FFFFFF"/>
-                </a:solidFill>
-                <a:latin typeface="NanumSquareOTF_ac"/>
-                <a:ea typeface="NanumSquareOTF_ac"/>
-              </a:rPr>
-              <a:t>소속 팀</a:t>
-            </a:r>
-          </a:p>
-        </p:txBody>
-      </p:sp>
-      <p:sp>
-        <p:nvSpPr>
-          <p:cNvPr id="5" name="TextBox 4"/>
+          <p:cNvPr id="4" name="TextBox 3"/>
           <p:cNvSpPr txBox="1"/>
           <p:nvPr/>
         </p:nvSpPr>
@@ -4050,7 +3969,7 @@
       </p:sp>
       <p:sp>
         <p:nvSpPr>
-          <p:cNvPr id="6" name="Rounded Rectangle 5"/>
+          <p:cNvPr id="5" name="Rounded Rectangle 4"/>
           <p:cNvSpPr/>
           <p:nvPr/>
         </p:nvSpPr>
@@ -4098,7 +4017,7 @@
       </p:sp>
       <p:sp>
         <p:nvSpPr>
-          <p:cNvPr id="7" name="Rounded Rectangle 6"/>
+          <p:cNvPr id="6" name="Rounded Rectangle 5"/>
           <p:cNvSpPr/>
           <p:nvPr/>
         </p:nvSpPr>
@@ -4161,7 +4080,7 @@
       </p:sp>
       <p:sp>
         <p:nvSpPr>
-          <p:cNvPr id="8" name="Rectangle 7"/>
+          <p:cNvPr id="7" name="Rectangle 6"/>
           <p:cNvSpPr/>
           <p:nvPr/>
         </p:nvSpPr>
@@ -4222,7 +4141,7 @@
       </p:sp>
       <p:sp>
         <p:nvSpPr>
-          <p:cNvPr id="9" name="TextBox 8"/>
+          <p:cNvPr id="8" name="TextBox 7"/>
           <p:cNvSpPr txBox="1"/>
           <p:nvPr/>
         </p:nvSpPr>
@@ -4268,7 +4187,7 @@
       </p:sp>
       <p:sp>
         <p:nvSpPr>
-          <p:cNvPr id="10" name="Rectangle 9"/>
+          <p:cNvPr id="9" name="Rectangle 8"/>
           <p:cNvSpPr/>
           <p:nvPr/>
         </p:nvSpPr>
@@ -4329,7 +4248,7 @@
       </p:sp>
       <p:sp>
         <p:nvSpPr>
-          <p:cNvPr id="11" name="TextBox 10"/>
+          <p:cNvPr id="10" name="TextBox 9"/>
           <p:cNvSpPr txBox="1"/>
           <p:nvPr/>
         </p:nvSpPr>
@@ -4368,14 +4287,14 @@
                 <a:latin typeface="NanumSquareOTF_ac"/>
                 <a:ea typeface="NanumSquareOTF_ac"/>
               </a:rPr>
-              <a:t>발표자 배지 · 포인트 액션</a:t>
-            </a:r>
-          </a:p>
-        </p:txBody>
-      </p:sp>
-      <p:sp>
-        <p:nvSpPr>
-          <p:cNvPr id="12" name="Rectangle 11"/>
+              <a:t>포인트 액션 · 링크</a:t>
+            </a:r>
+          </a:p>
+        </p:txBody>
+      </p:sp>
+      <p:sp>
+        <p:nvSpPr>
+          <p:cNvPr id="11" name="Rectangle 10"/>
           <p:cNvSpPr/>
           <p:nvPr/>
         </p:nvSpPr>
@@ -4436,7 +4355,7 @@
       </p:sp>
       <p:sp>
         <p:nvSpPr>
-          <p:cNvPr id="13" name="TextBox 12"/>
+          <p:cNvPr id="12" name="TextBox 11"/>
           <p:cNvSpPr txBox="1"/>
           <p:nvPr/>
         </p:nvSpPr>
@@ -4482,7 +4401,7 @@
       </p:sp>
       <p:sp>
         <p:nvSpPr>
-          <p:cNvPr id="14" name="Rectangle 13"/>
+          <p:cNvPr id="13" name="Rectangle 12"/>
           <p:cNvSpPr/>
           <p:nvPr/>
         </p:nvSpPr>
@@ -4543,7 +4462,7 @@
       </p:sp>
       <p:sp>
         <p:nvSpPr>
-          <p:cNvPr id="15" name="TextBox 14"/>
+          <p:cNvPr id="14" name="TextBox 13"/>
           <p:cNvSpPr txBox="1"/>
           <p:nvPr/>
         </p:nvSpPr>
@@ -4589,7 +4508,7 @@
       </p:sp>
       <p:sp>
         <p:nvSpPr>
-          <p:cNvPr id="16" name="Rectangle 15"/>
+          <p:cNvPr id="15" name="Rectangle 14"/>
           <p:cNvSpPr/>
           <p:nvPr/>
         </p:nvSpPr>
@@ -4652,7 +4571,7 @@
       </p:sp>
       <p:sp>
         <p:nvSpPr>
-          <p:cNvPr id="17" name="TextBox 16"/>
+          <p:cNvPr id="16" name="TextBox 15"/>
           <p:cNvSpPr txBox="1"/>
           <p:nvPr/>
         </p:nvSpPr>
@@ -4698,7 +4617,7 @@
       </p:sp>
       <p:sp>
         <p:nvSpPr>
-          <p:cNvPr id="18" name="Rectangle 17"/>
+          <p:cNvPr id="17" name="Rectangle 16"/>
           <p:cNvSpPr/>
           <p:nvPr/>
         </p:nvSpPr>
@@ -4761,7 +4680,7 @@
       </p:sp>
       <p:sp>
         <p:nvSpPr>
-          <p:cNvPr id="19" name="TextBox 18"/>
+          <p:cNvPr id="18" name="TextBox 17"/>
           <p:cNvSpPr txBox="1"/>
           <p:nvPr/>
         </p:nvSpPr>
@@ -4807,7 +4726,7 @@
       </p:sp>
       <p:sp>
         <p:nvSpPr>
-          <p:cNvPr id="20" name="Rounded Rectangle 19"/>
+          <p:cNvPr id="19" name="Rounded Rectangle 18"/>
           <p:cNvSpPr/>
           <p:nvPr/>
         </p:nvSpPr>
@@ -4855,7 +4774,7 @@
       </p:sp>
       <p:sp>
         <p:nvSpPr>
-          <p:cNvPr id="21" name="Rounded Rectangle 20"/>
+          <p:cNvPr id="20" name="Rounded Rectangle 19"/>
           <p:cNvSpPr/>
           <p:nvPr/>
         </p:nvSpPr>
@@ -4918,7 +4837,7 @@
       </p:sp>
       <p:sp>
         <p:nvSpPr>
-          <p:cNvPr id="22" name="TextBox 21"/>
+          <p:cNvPr id="21" name="TextBox 20"/>
           <p:cNvSpPr txBox="1"/>
           <p:nvPr/>
         </p:nvSpPr>
@@ -5079,7 +4998,7 @@
       </p:sp>
       <p:sp>
         <p:nvSpPr>
-          <p:cNvPr id="23" name="TextBox 22"/>
+          <p:cNvPr id="22" name="TextBox 21"/>
           <p:cNvSpPr txBox="1"/>
           <p:nvPr/>
         </p:nvSpPr>
@@ -5125,7 +5044,7 @@
       </p:sp>
       <p:sp>
         <p:nvSpPr>
-          <p:cNvPr id="24" name="Rounded Rectangle 23"/>
+          <p:cNvPr id="23" name="Rounded Rectangle 22"/>
           <p:cNvSpPr/>
           <p:nvPr/>
         </p:nvSpPr>
@@ -5311,87 +5230,6 @@
         </p:nvSpPr>
         <p:spPr>
           <a:xfrm>
-            <a:off x="10058400" y="164592"/>
-            <a:ext cx="1737360" cy="603504"/>
-          </a:xfrm>
-          <a:prstGeom prst="rect">
-            <a:avLst/>
-          </a:prstGeom>
-          <a:solidFill>
-            <a:srgbClr val="1273C4"/>
-          </a:solidFill>
-          <a:ln>
-            <a:noFill/>
-          </a:ln>
-          <a:effectLst/>
-        </p:spPr>
-        <p:style>
-          <a:lnRef idx="1">
-            <a:schemeClr val="accent1"/>
-          </a:lnRef>
-          <a:fillRef idx="3">
-            <a:schemeClr val="accent1"/>
-          </a:fillRef>
-          <a:effectRef idx="2">
-            <a:schemeClr val="accent1"/>
-          </a:effectRef>
-          <a:fontRef idx="minor">
-            <a:schemeClr val="lt1"/>
-          </a:fontRef>
-        </p:style>
-        <p:txBody>
-          <a:bodyPr rtlCol="0" anchor="ctr" wrap="square" lIns="50800" rIns="50800" tIns="25400" bIns="25400"/>
-          <a:lstStyle/>
-          <a:p>
-            <a:pPr algn="ctr">
-              <a:spcBef>
-                <a:spcPts val="0"/>
-              </a:spcBef>
-              <a:spcAft>
-                <a:spcPts val="0"/>
-              </a:spcAft>
-            </a:pPr>
-            <a:r>
-              <a:rPr sz="1400" b="0">
-                <a:solidFill>
-                  <a:srgbClr val="FFFFFF"/>
-                </a:solidFill>
-                <a:latin typeface="NanumSquareOTF_ac ExtraBold"/>
-                <a:ea typeface="NanumSquareOTF_ac ExtraBold"/>
-              </a:rPr>
-              <a:t>발표자</a:t>
-            </a:r>
-          </a:p>
-          <a:p>
-            <a:pPr algn="ctr">
-              <a:spcBef>
-                <a:spcPts val="0"/>
-              </a:spcBef>
-              <a:spcAft>
-                <a:spcPts val="0"/>
-              </a:spcAft>
-            </a:pPr>
-            <a:r>
-              <a:rPr sz="1000" b="0">
-                <a:solidFill>
-                  <a:srgbClr val="FFFFFF"/>
-                </a:solidFill>
-                <a:latin typeface="NanumSquareOTF_ac"/>
-                <a:ea typeface="NanumSquareOTF_ac"/>
-              </a:rPr>
-              <a:t>소속 팀</a:t>
-            </a:r>
-          </a:p>
-        </p:txBody>
-      </p:sp>
-      <p:sp>
-        <p:nvSpPr>
-          <p:cNvPr id="5" name="Rectangle 4"/>
-          <p:cNvSpPr/>
-          <p:nvPr/>
-        </p:nvSpPr>
-        <p:spPr>
-          <a:xfrm>
             <a:off x="411480" y="164592"/>
             <a:ext cx="11365992" cy="731520"/>
           </a:xfrm>
@@ -5431,7 +5269,7 @@
       </p:sp>
       <p:sp>
         <p:nvSpPr>
-          <p:cNvPr id="6" name="Rectangle 5"/>
+          <p:cNvPr id="5" name="Rectangle 4"/>
           <p:cNvSpPr/>
           <p:nvPr/>
         </p:nvSpPr>
@@ -5476,7 +5314,7 @@
       </p:sp>
       <p:sp>
         <p:nvSpPr>
-          <p:cNvPr id="7" name="TextBox 6"/>
+          <p:cNvPr id="6" name="TextBox 5"/>
           <p:cNvSpPr txBox="1"/>
           <p:nvPr/>
         </p:nvSpPr>
@@ -5519,7 +5357,7 @@
       </p:sp>
       <p:sp>
         <p:nvSpPr>
-          <p:cNvPr id="8" name="Rectangle 7"/>
+          <p:cNvPr id="7" name="Rectangle 6"/>
           <p:cNvSpPr/>
           <p:nvPr/>
         </p:nvSpPr>
@@ -5564,7 +5402,7 @@
       </p:sp>
       <p:sp>
         <p:nvSpPr>
-          <p:cNvPr id="9" name="TextBox 8"/>
+          <p:cNvPr id="8" name="TextBox 7"/>
           <p:cNvSpPr txBox="1"/>
           <p:nvPr/>
         </p:nvSpPr>
@@ -5607,7 +5445,7 @@
       </p:sp>
       <p:sp>
         <p:nvSpPr>
-          <p:cNvPr id="10" name="Rectangle 9"/>
+          <p:cNvPr id="9" name="Rectangle 8"/>
           <p:cNvSpPr/>
           <p:nvPr/>
         </p:nvSpPr>
@@ -5652,7 +5490,7 @@
       </p:sp>
       <p:sp>
         <p:nvSpPr>
-          <p:cNvPr id="11" name="TextBox 10"/>
+          <p:cNvPr id="10" name="TextBox 9"/>
           <p:cNvSpPr txBox="1"/>
           <p:nvPr/>
         </p:nvSpPr>
@@ -5695,7 +5533,7 @@
       </p:sp>
       <p:sp>
         <p:nvSpPr>
-          <p:cNvPr id="12" name="Rectangle 11"/>
+          <p:cNvPr id="11" name="Rectangle 10"/>
           <p:cNvSpPr/>
           <p:nvPr/>
         </p:nvSpPr>
@@ -5740,7 +5578,7 @@
       </p:sp>
       <p:sp>
         <p:nvSpPr>
-          <p:cNvPr id="13" name="TextBox 12"/>
+          <p:cNvPr id="12" name="TextBox 11"/>
           <p:cNvSpPr txBox="1"/>
           <p:nvPr/>
         </p:nvSpPr>
@@ -5779,14 +5617,14 @@
                 <a:latin typeface="NanumSquareOTF_ac"/>
                 <a:ea typeface="NanumSquareOTF_ac"/>
               </a:rPr>
-              <a:t>① Header — 덱이름 | 섹션명 + 발표자 배지 + 룰</a:t>
-            </a:r>
-          </a:p>
-        </p:txBody>
-      </p:sp>
-      <p:sp>
-        <p:nvSpPr>
-          <p:cNvPr id="14" name="TextBox 13"/>
+              <a:t>① Header — 덱이름 | 섹션명 + 룰</a:t>
+            </a:r>
+          </a:p>
+        </p:txBody>
+      </p:sp>
+      <p:sp>
+        <p:nvSpPr>
+          <p:cNvPr id="13" name="TextBox 12"/>
           <p:cNvSpPr txBox="1"/>
           <p:nvPr/>
         </p:nvSpPr>
@@ -5832,7 +5670,7 @@
       </p:sp>
       <p:sp>
         <p:nvSpPr>
-          <p:cNvPr id="15" name="TextBox 14"/>
+          <p:cNvPr id="14" name="TextBox 13"/>
           <p:cNvSpPr txBox="1"/>
           <p:nvPr/>
         </p:nvSpPr>
@@ -5995,88 +5833,7 @@
       </p:cxnSp>
       <p:sp>
         <p:nvSpPr>
-          <p:cNvPr id="4" name="Rectangle 3"/>
-          <p:cNvSpPr/>
-          <p:nvPr/>
-        </p:nvSpPr>
-        <p:spPr>
-          <a:xfrm>
-            <a:off x="10058400" y="164592"/>
-            <a:ext cx="1737360" cy="603504"/>
-          </a:xfrm>
-          <a:prstGeom prst="rect">
-            <a:avLst/>
-          </a:prstGeom>
-          <a:solidFill>
-            <a:srgbClr val="1273C4"/>
-          </a:solidFill>
-          <a:ln>
-            <a:noFill/>
-          </a:ln>
-          <a:effectLst/>
-        </p:spPr>
-        <p:style>
-          <a:lnRef idx="1">
-            <a:schemeClr val="accent1"/>
-          </a:lnRef>
-          <a:fillRef idx="3">
-            <a:schemeClr val="accent1"/>
-          </a:fillRef>
-          <a:effectRef idx="2">
-            <a:schemeClr val="accent1"/>
-          </a:effectRef>
-          <a:fontRef idx="minor">
-            <a:schemeClr val="lt1"/>
-          </a:fontRef>
-        </p:style>
-        <p:txBody>
-          <a:bodyPr rtlCol="0" anchor="ctr" wrap="square" lIns="50800" rIns="50800" tIns="25400" bIns="25400"/>
-          <a:lstStyle/>
-          <a:p>
-            <a:pPr algn="ctr">
-              <a:spcBef>
-                <a:spcPts val="0"/>
-              </a:spcBef>
-              <a:spcAft>
-                <a:spcPts val="0"/>
-              </a:spcAft>
-            </a:pPr>
-            <a:r>
-              <a:rPr sz="1400" b="0">
-                <a:solidFill>
-                  <a:srgbClr val="FFFFFF"/>
-                </a:solidFill>
-                <a:latin typeface="NanumSquareOTF_ac ExtraBold"/>
-                <a:ea typeface="NanumSquareOTF_ac ExtraBold"/>
-              </a:rPr>
-              <a:t>발표자</a:t>
-            </a:r>
-          </a:p>
-          <a:p>
-            <a:pPr algn="ctr">
-              <a:spcBef>
-                <a:spcPts val="0"/>
-              </a:spcBef>
-              <a:spcAft>
-                <a:spcPts val="0"/>
-              </a:spcAft>
-            </a:pPr>
-            <a:r>
-              <a:rPr sz="1000" b="0">
-                <a:solidFill>
-                  <a:srgbClr val="FFFFFF"/>
-                </a:solidFill>
-                <a:latin typeface="NanumSquareOTF_ac"/>
-                <a:ea typeface="NanumSquareOTF_ac"/>
-              </a:rPr>
-              <a:t>소속 팀</a:t>
-            </a:r>
-          </a:p>
-        </p:txBody>
-      </p:sp>
-      <p:sp>
-        <p:nvSpPr>
-          <p:cNvPr id="5" name="TextBox 4"/>
+          <p:cNvPr id="4" name="TextBox 3"/>
           <p:cNvSpPr txBox="1"/>
           <p:nvPr/>
         </p:nvSpPr>
@@ -6112,14 +5869,14 @@
                 <a:latin typeface="NanumSquareOTF_ac ExtraBold"/>
                 <a:ea typeface="NanumSquareOTF_ac ExtraBold"/>
               </a:rPr>
-              <a:t>10개 컴포넌트의 조합만으로 모든 슬라이드를 구성</a:t>
-            </a:r>
-          </a:p>
-        </p:txBody>
-      </p:sp>
-      <p:sp>
-        <p:nvSpPr>
-          <p:cNvPr id="6" name="Rounded Rectangle 5"/>
+              <a:t>핵심 컴포넌트의 조합만으로 모든 슬라이드를 구성</a:t>
+            </a:r>
+          </a:p>
+        </p:txBody>
+      </p:sp>
+      <p:sp>
+        <p:nvSpPr>
+          <p:cNvPr id="5" name="Rounded Rectangle 4"/>
           <p:cNvSpPr/>
           <p:nvPr/>
         </p:nvSpPr>
@@ -6167,7 +5924,7 @@
       </p:sp>
       <p:sp>
         <p:nvSpPr>
-          <p:cNvPr id="7" name="Rounded Rectangle 6"/>
+          <p:cNvPr id="6" name="Rounded Rectangle 5"/>
           <p:cNvSpPr/>
           <p:nvPr/>
         </p:nvSpPr>
@@ -6230,7 +5987,7 @@
       </p:sp>
       <p:sp>
         <p:nvSpPr>
-          <p:cNvPr id="8" name="TextBox 7"/>
+          <p:cNvPr id="7" name="TextBox 6"/>
           <p:cNvSpPr txBox="1"/>
           <p:nvPr/>
         </p:nvSpPr>
@@ -6276,7 +6033,7 @@
       </p:sp>
       <p:sp>
         <p:nvSpPr>
-          <p:cNvPr id="9" name="Rectangle 8"/>
+          <p:cNvPr id="8" name="Rectangle 7"/>
           <p:cNvSpPr/>
           <p:nvPr/>
         </p:nvSpPr>
@@ -6340,7 +6097,7 @@
       </p:sp>
       <p:sp>
         <p:nvSpPr>
-          <p:cNvPr id="10" name="TextBox 9"/>
+          <p:cNvPr id="9" name="TextBox 8"/>
           <p:cNvSpPr txBox="1"/>
           <p:nvPr/>
         </p:nvSpPr>
@@ -6409,7 +6166,7 @@
       </p:sp>
       <p:sp>
         <p:nvSpPr>
-          <p:cNvPr id="11" name="TextBox 10"/>
+          <p:cNvPr id="10" name="TextBox 9"/>
           <p:cNvSpPr txBox="1"/>
           <p:nvPr/>
         </p:nvSpPr>
@@ -6455,134 +6212,7 @@
       </p:sp>
       <p:sp>
         <p:nvSpPr>
-          <p:cNvPr id="12" name="Rectangle 11"/>
-          <p:cNvSpPr/>
-          <p:nvPr/>
-        </p:nvSpPr>
-        <p:spPr>
-          <a:xfrm>
-            <a:off x="8595360" y="2286000"/>
-            <a:ext cx="1737360" cy="603504"/>
-          </a:xfrm>
-          <a:prstGeom prst="rect">
-            <a:avLst/>
-          </a:prstGeom>
-          <a:solidFill>
-            <a:srgbClr val="1273C4"/>
-          </a:solidFill>
-          <a:ln>
-            <a:noFill/>
-          </a:ln>
-          <a:effectLst/>
-        </p:spPr>
-        <p:style>
-          <a:lnRef idx="1">
-            <a:schemeClr val="accent1"/>
-          </a:lnRef>
-          <a:fillRef idx="3">
-            <a:schemeClr val="accent1"/>
-          </a:fillRef>
-          <a:effectRef idx="2">
-            <a:schemeClr val="accent1"/>
-          </a:effectRef>
-          <a:fontRef idx="minor">
-            <a:schemeClr val="lt1"/>
-          </a:fontRef>
-        </p:style>
-        <p:txBody>
-          <a:bodyPr rtlCol="0" anchor="ctr" wrap="square" lIns="50800" rIns="50800" tIns="25400" bIns="25400"/>
-          <a:lstStyle/>
-          <a:p>
-            <a:pPr algn="ctr">
-              <a:spcBef>
-                <a:spcPts val="0"/>
-              </a:spcBef>
-              <a:spcAft>
-                <a:spcPts val="0"/>
-              </a:spcAft>
-            </a:pPr>
-            <a:r>
-              <a:rPr sz="1400" b="0">
-                <a:solidFill>
-                  <a:srgbClr val="FFFFFF"/>
-                </a:solidFill>
-                <a:latin typeface="NanumSquareOTF_ac ExtraBold"/>
-                <a:ea typeface="NanumSquareOTF_ac ExtraBold"/>
-              </a:rPr>
-              <a:t>김강호</a:t>
-            </a:r>
-          </a:p>
-          <a:p>
-            <a:pPr algn="ctr">
-              <a:spcBef>
-                <a:spcPts val="0"/>
-              </a:spcBef>
-              <a:spcAft>
-                <a:spcPts val="0"/>
-              </a:spcAft>
-            </a:pPr>
-            <a:r>
-              <a:rPr sz="1000" b="0">
-                <a:solidFill>
-                  <a:srgbClr val="FFFFFF"/>
-                </a:solidFill>
-                <a:latin typeface="NanumSquareOTF_ac"/>
-                <a:ea typeface="NanumSquareOTF_ac"/>
-              </a:rPr>
-              <a:t>Access Tech.팀</a:t>
-            </a:r>
-          </a:p>
-        </p:txBody>
-      </p:sp>
-      <p:sp>
-        <p:nvSpPr>
-          <p:cNvPr id="13" name="TextBox 12"/>
-          <p:cNvSpPr txBox="1"/>
-          <p:nvPr/>
-        </p:nvSpPr>
-        <p:spPr>
-          <a:xfrm>
-            <a:off x="8595360" y="3566160"/>
-            <a:ext cx="1737360" cy="320040"/>
-          </a:xfrm>
-          <a:prstGeom prst="rect">
-            <a:avLst/>
-          </a:prstGeom>
-          <a:noFill/>
-        </p:spPr>
-        <p:txBody>
-          <a:bodyPr wrap="square" anchor="t" lIns="50800" rIns="50800" tIns="25400" bIns="25400">
-            <a:spAutoFit/>
-          </a:bodyPr>
-          <a:lstStyle/>
-          <a:p>
-            <a:pPr algn="ctr">
-              <a:lnSpc>
-                <a:spcPct val="115000"/>
-              </a:lnSpc>
-              <a:spcBef>
-                <a:spcPts val="0"/>
-              </a:spcBef>
-              <a:spcAft>
-                <a:spcPts val="0"/>
-              </a:spcAft>
-            </a:pPr>
-            <a:r>
-              <a:rPr sz="1000" b="0">
-                <a:solidFill>
-                  <a:srgbClr val="7F7F7F"/>
-                </a:solidFill>
-                <a:latin typeface="NanumSquareOTF_ac"/>
-                <a:ea typeface="NanumSquareOTF_ac"/>
-              </a:rPr>
-              <a:t>Presenter Badge</a:t>
-            </a:r>
-          </a:p>
-        </p:txBody>
-      </p:sp>
-      <p:sp>
-        <p:nvSpPr>
-          <p:cNvPr id="14" name="Rectangle 13"/>
+          <p:cNvPr id="11" name="Rectangle 10"/>
           <p:cNvSpPr/>
           <p:nvPr/>
         </p:nvSpPr>
@@ -6643,7 +6273,7 @@
       </p:sp>
       <p:sp>
         <p:nvSpPr>
-          <p:cNvPr id="15" name="TextBox 14"/>
+          <p:cNvPr id="12" name="TextBox 11"/>
           <p:cNvSpPr txBox="1"/>
           <p:nvPr/>
         </p:nvSpPr>
@@ -6689,7 +6319,7 @@
       </p:sp>
       <p:cxnSp>
         <p:nvCxnSpPr>
-          <p:cNvPr id="16" name="Connector 15"/>
+          <p:cNvPr id="13" name="Connector 12"/>
           <p:cNvCxnSpPr/>
           <p:nvPr/>
         </p:nvCxnSpPr>
@@ -6725,7 +6355,7 @@
       </p:cxnSp>
       <p:sp>
         <p:nvSpPr>
-          <p:cNvPr id="17" name="Oval 16"/>
+          <p:cNvPr id="14" name="Oval 13"/>
           <p:cNvSpPr/>
           <p:nvPr/>
         </p:nvSpPr>
@@ -6769,7 +6399,7 @@
       </p:sp>
       <p:sp>
         <p:nvSpPr>
-          <p:cNvPr id="18" name="TextBox 17"/>
+          <p:cNvPr id="15" name="TextBox 14"/>
           <p:cNvSpPr txBox="1"/>
           <p:nvPr/>
         </p:nvSpPr>
@@ -6812,7 +6442,7 @@
       </p:sp>
       <p:sp>
         <p:nvSpPr>
-          <p:cNvPr id="19" name="Oval 18"/>
+          <p:cNvPr id="16" name="Oval 15"/>
           <p:cNvSpPr/>
           <p:nvPr/>
         </p:nvSpPr>
@@ -6858,7 +6488,7 @@
       </p:sp>
       <p:sp>
         <p:nvSpPr>
-          <p:cNvPr id="20" name="TextBox 19"/>
+          <p:cNvPr id="17" name="TextBox 16"/>
           <p:cNvSpPr txBox="1"/>
           <p:nvPr/>
         </p:nvSpPr>
@@ -6901,7 +6531,7 @@
       </p:sp>
       <p:sp>
         <p:nvSpPr>
-          <p:cNvPr id="21" name="Oval 20"/>
+          <p:cNvPr id="18" name="Oval 17"/>
           <p:cNvSpPr/>
           <p:nvPr/>
         </p:nvSpPr>
@@ -6947,7 +6577,7 @@
       </p:sp>
       <p:sp>
         <p:nvSpPr>
-          <p:cNvPr id="22" name="TextBox 21"/>
+          <p:cNvPr id="19" name="TextBox 18"/>
           <p:cNvSpPr txBox="1"/>
           <p:nvPr/>
         </p:nvSpPr>
@@ -6990,7 +6620,7 @@
       </p:sp>
       <p:sp>
         <p:nvSpPr>
-          <p:cNvPr id="23" name="TextBox 22"/>
+          <p:cNvPr id="20" name="TextBox 19"/>
           <p:cNvSpPr txBox="1"/>
           <p:nvPr/>
         </p:nvSpPr>
@@ -7036,7 +6666,7 @@
       </p:sp>
       <p:sp>
         <p:nvSpPr>
-          <p:cNvPr id="24" name="Rectangle 23"/>
+          <p:cNvPr id="21" name="Rectangle 20"/>
           <p:cNvSpPr/>
           <p:nvPr/>
         </p:nvSpPr>
@@ -7100,7 +6730,7 @@
       </p:sp>
       <p:sp>
         <p:nvSpPr>
-          <p:cNvPr id="25" name="Rectangle 24"/>
+          <p:cNvPr id="22" name="Rectangle 21"/>
           <p:cNvSpPr/>
           <p:nvPr/>
         </p:nvSpPr>
@@ -7164,7 +6794,7 @@
       </p:sp>
       <p:sp>
         <p:nvSpPr>
-          <p:cNvPr id="26" name="Rectangle 25"/>
+          <p:cNvPr id="23" name="Rectangle 22"/>
           <p:cNvSpPr/>
           <p:nvPr/>
         </p:nvSpPr>
@@ -7231,7 +6861,7 @@
       </p:sp>
       <p:sp>
         <p:nvSpPr>
-          <p:cNvPr id="27" name="TextBox 26"/>
+          <p:cNvPr id="24" name="TextBox 23"/>
           <p:cNvSpPr txBox="1"/>
           <p:nvPr/>
         </p:nvSpPr>
@@ -7277,7 +6907,7 @@
       </p:sp>
       <p:sp>
         <p:nvSpPr>
-          <p:cNvPr id="28" name="Right Arrow 27"/>
+          <p:cNvPr id="25" name="Right Arrow 24"/>
           <p:cNvSpPr/>
           <p:nvPr/>
         </p:nvSpPr>
@@ -7321,7 +6951,7 @@
       </p:sp>
       <p:sp>
         <p:nvSpPr>
-          <p:cNvPr id="29" name="Pentagon 28"/>
+          <p:cNvPr id="26" name="Pentagon 25"/>
           <p:cNvSpPr/>
           <p:nvPr/>
         </p:nvSpPr>
@@ -7382,7 +7012,7 @@
       </p:sp>
       <p:sp>
         <p:nvSpPr>
-          <p:cNvPr id="30" name="TextBox 29"/>
+          <p:cNvPr id="27" name="TextBox 26"/>
           <p:cNvSpPr txBox="1"/>
           <p:nvPr/>
         </p:nvSpPr>
@@ -7428,7 +7058,7 @@
       </p:sp>
       <p:sp>
         <p:nvSpPr>
-          <p:cNvPr id="31" name="Rounded Rectangle 30"/>
+          <p:cNvPr id="28" name="Rounded Rectangle 27"/>
           <p:cNvSpPr/>
           <p:nvPr/>
         </p:nvSpPr>
@@ -7608,88 +7238,7 @@
       </p:cxnSp>
       <p:sp>
         <p:nvSpPr>
-          <p:cNvPr id="4" name="Rectangle 3"/>
-          <p:cNvSpPr/>
-          <p:nvPr/>
-        </p:nvSpPr>
-        <p:spPr>
-          <a:xfrm>
-            <a:off x="10058400" y="164592"/>
-            <a:ext cx="1737360" cy="603504"/>
-          </a:xfrm>
-          <a:prstGeom prst="rect">
-            <a:avLst/>
-          </a:prstGeom>
-          <a:solidFill>
-            <a:srgbClr val="1273C4"/>
-          </a:solidFill>
-          <a:ln>
-            <a:noFill/>
-          </a:ln>
-          <a:effectLst/>
-        </p:spPr>
-        <p:style>
-          <a:lnRef idx="1">
-            <a:schemeClr val="accent1"/>
-          </a:lnRef>
-          <a:fillRef idx="3">
-            <a:schemeClr val="accent1"/>
-          </a:fillRef>
-          <a:effectRef idx="2">
-            <a:schemeClr val="accent1"/>
-          </a:effectRef>
-          <a:fontRef idx="minor">
-            <a:schemeClr val="lt1"/>
-          </a:fontRef>
-        </p:style>
-        <p:txBody>
-          <a:bodyPr rtlCol="0" anchor="ctr" wrap="square" lIns="50800" rIns="50800" tIns="25400" bIns="25400"/>
-          <a:lstStyle/>
-          <a:p>
-            <a:pPr algn="ctr">
-              <a:spcBef>
-                <a:spcPts val="0"/>
-              </a:spcBef>
-              <a:spcAft>
-                <a:spcPts val="0"/>
-              </a:spcAft>
-            </a:pPr>
-            <a:r>
-              <a:rPr sz="1400" b="0">
-                <a:solidFill>
-                  <a:srgbClr val="FFFFFF"/>
-                </a:solidFill>
-                <a:latin typeface="NanumSquareOTF_ac ExtraBold"/>
-                <a:ea typeface="NanumSquareOTF_ac ExtraBold"/>
-              </a:rPr>
-              <a:t>김강호</a:t>
-            </a:r>
-          </a:p>
-          <a:p>
-            <a:pPr algn="ctr">
-              <a:spcBef>
-                <a:spcPts val="0"/>
-              </a:spcBef>
-              <a:spcAft>
-                <a:spcPts val="0"/>
-              </a:spcAft>
-            </a:pPr>
-            <a:r>
-              <a:rPr sz="1000" b="0">
-                <a:solidFill>
-                  <a:srgbClr val="FFFFFF"/>
-                </a:solidFill>
-                <a:latin typeface="NanumSquareOTF_ac"/>
-                <a:ea typeface="NanumSquareOTF_ac"/>
-              </a:rPr>
-              <a:t>Access Tech.팀</a:t>
-            </a:r>
-          </a:p>
-        </p:txBody>
-      </p:sp>
-      <p:sp>
-        <p:nvSpPr>
-          <p:cNvPr id="5" name="TextBox 4"/>
+          <p:cNvPr id="4" name="TextBox 3"/>
           <p:cNvSpPr txBox="1"/>
           <p:nvPr/>
         </p:nvSpPr>
@@ -7732,7 +7281,7 @@
       </p:sp>
       <p:sp>
         <p:nvSpPr>
-          <p:cNvPr id="6" name="Rounded Rectangle 5"/>
+          <p:cNvPr id="5" name="Rounded Rectangle 4"/>
           <p:cNvSpPr/>
           <p:nvPr/>
         </p:nvSpPr>
@@ -7780,7 +7329,7 @@
       </p:sp>
       <p:sp>
         <p:nvSpPr>
-          <p:cNvPr id="7" name="Rounded Rectangle 6"/>
+          <p:cNvPr id="6" name="Rounded Rectangle 5"/>
           <p:cNvSpPr/>
           <p:nvPr/>
         </p:nvSpPr>
@@ -7843,7 +7392,7 @@
       </p:sp>
       <p:sp>
         <p:nvSpPr>
-          <p:cNvPr id="8" name="TextBox 7"/>
+          <p:cNvPr id="7" name="TextBox 6"/>
           <p:cNvSpPr txBox="1"/>
           <p:nvPr/>
         </p:nvSpPr>
@@ -7889,7 +7438,7 @@
       </p:sp>
       <p:cxnSp>
         <p:nvCxnSpPr>
-          <p:cNvPr id="9" name="Connector 8"/>
+          <p:cNvPr id="8" name="Connector 7"/>
           <p:cNvCxnSpPr/>
           <p:nvPr/>
         </p:nvCxnSpPr>
@@ -7925,7 +7474,7 @@
       </p:cxnSp>
       <p:sp>
         <p:nvSpPr>
-          <p:cNvPr id="10" name="Rectangle 9"/>
+          <p:cNvPr id="9" name="Rectangle 8"/>
           <p:cNvSpPr/>
           <p:nvPr/>
         </p:nvSpPr>
@@ -7989,7 +7538,7 @@
       </p:sp>
       <p:sp>
         <p:nvSpPr>
-          <p:cNvPr id="11" name="TextBox 10"/>
+          <p:cNvPr id="10" name="TextBox 9"/>
           <p:cNvSpPr txBox="1"/>
           <p:nvPr/>
         </p:nvSpPr>
@@ -8058,7 +7607,7 @@
       </p:sp>
       <p:sp>
         <p:nvSpPr>
-          <p:cNvPr id="12" name="Rectangle 11"/>
+          <p:cNvPr id="11" name="Rectangle 10"/>
           <p:cNvSpPr/>
           <p:nvPr/>
         </p:nvSpPr>
@@ -8122,7 +7671,7 @@
       </p:sp>
       <p:sp>
         <p:nvSpPr>
-          <p:cNvPr id="13" name="TextBox 12"/>
+          <p:cNvPr id="12" name="TextBox 11"/>
           <p:cNvSpPr txBox="1"/>
           <p:nvPr/>
         </p:nvSpPr>
@@ -8191,7 +7740,7 @@
       </p:sp>
       <p:sp>
         <p:nvSpPr>
-          <p:cNvPr id="14" name="Rectangle 13"/>
+          <p:cNvPr id="13" name="Rectangle 12"/>
           <p:cNvSpPr/>
           <p:nvPr/>
         </p:nvSpPr>
@@ -8255,7 +7804,7 @@
       </p:sp>
       <p:sp>
         <p:nvSpPr>
-          <p:cNvPr id="15" name="TextBox 14"/>
+          <p:cNvPr id="14" name="TextBox 13"/>
           <p:cNvSpPr txBox="1"/>
           <p:nvPr/>
         </p:nvSpPr>
@@ -8324,7 +7873,7 @@
       </p:sp>
       <p:sp>
         <p:nvSpPr>
-          <p:cNvPr id="16" name="Rectangle 15"/>
+          <p:cNvPr id="15" name="Rectangle 14"/>
           <p:cNvSpPr/>
           <p:nvPr/>
         </p:nvSpPr>
@@ -8385,7 +7934,7 @@
       </p:sp>
       <p:sp>
         <p:nvSpPr>
-          <p:cNvPr id="17" name="Rounded Rectangle 16"/>
+          <p:cNvPr id="16" name="Rounded Rectangle 15"/>
           <p:cNvSpPr/>
           <p:nvPr/>
         </p:nvSpPr>
@@ -8433,7 +7982,7 @@
       </p:sp>
       <p:sp>
         <p:nvSpPr>
-          <p:cNvPr id="18" name="Rounded Rectangle 17"/>
+          <p:cNvPr id="17" name="Rounded Rectangle 16"/>
           <p:cNvSpPr/>
           <p:nvPr/>
         </p:nvSpPr>
@@ -8496,7 +8045,7 @@
       </p:sp>
       <p:sp>
         <p:nvSpPr>
-          <p:cNvPr id="19" name="TextBox 18"/>
+          <p:cNvPr id="18" name="TextBox 17"/>
           <p:cNvSpPr txBox="1"/>
           <p:nvPr/>
         </p:nvSpPr>
@@ -8542,7 +8091,7 @@
       </p:sp>
       <p:cxnSp>
         <p:nvCxnSpPr>
-          <p:cNvPr id="20" name="Connector 19"/>
+          <p:cNvPr id="19" name="Connector 18"/>
           <p:cNvCxnSpPr/>
           <p:nvPr/>
         </p:nvCxnSpPr>
@@ -8578,7 +8127,7 @@
       </p:cxnSp>
       <p:sp>
         <p:nvSpPr>
-          <p:cNvPr id="21" name="Oval 20"/>
+          <p:cNvPr id="20" name="Oval 19"/>
           <p:cNvSpPr/>
           <p:nvPr/>
         </p:nvSpPr>
@@ -8622,7 +8171,7 @@
       </p:sp>
       <p:sp>
         <p:nvSpPr>
-          <p:cNvPr id="22" name="TextBox 21"/>
+          <p:cNvPr id="21" name="TextBox 20"/>
           <p:cNvSpPr txBox="1"/>
           <p:nvPr/>
         </p:nvSpPr>
@@ -8685,7 +8234,7 @@
       </p:sp>
       <p:sp>
         <p:nvSpPr>
-          <p:cNvPr id="23" name="Oval 22"/>
+          <p:cNvPr id="22" name="Oval 21"/>
           <p:cNvSpPr/>
           <p:nvPr/>
         </p:nvSpPr>
@@ -8731,7 +8280,7 @@
       </p:sp>
       <p:sp>
         <p:nvSpPr>
-          <p:cNvPr id="24" name="TextBox 23"/>
+          <p:cNvPr id="23" name="TextBox 22"/>
           <p:cNvSpPr txBox="1"/>
           <p:nvPr/>
         </p:nvSpPr>
@@ -8794,7 +8343,7 @@
       </p:sp>
       <p:sp>
         <p:nvSpPr>
-          <p:cNvPr id="25" name="Oval 24"/>
+          <p:cNvPr id="24" name="Oval 23"/>
           <p:cNvSpPr/>
           <p:nvPr/>
         </p:nvSpPr>
@@ -8838,7 +8387,7 @@
       </p:sp>
       <p:sp>
         <p:nvSpPr>
-          <p:cNvPr id="26" name="TextBox 25"/>
+          <p:cNvPr id="25" name="TextBox 24"/>
           <p:cNvSpPr txBox="1"/>
           <p:nvPr/>
         </p:nvSpPr>
@@ -8901,7 +8450,7 @@
       </p:sp>
       <p:sp>
         <p:nvSpPr>
-          <p:cNvPr id="27" name="Oval 26"/>
+          <p:cNvPr id="26" name="Oval 25"/>
           <p:cNvSpPr/>
           <p:nvPr/>
         </p:nvSpPr>
@@ -8947,7 +8496,7 @@
       </p:sp>
       <p:sp>
         <p:nvSpPr>
-          <p:cNvPr id="28" name="TextBox 27"/>
+          <p:cNvPr id="27" name="TextBox 26"/>
           <p:cNvSpPr txBox="1"/>
           <p:nvPr/>
         </p:nvSpPr>
@@ -9010,7 +8559,7 @@
       </p:sp>
       <p:sp>
         <p:nvSpPr>
-          <p:cNvPr id="29" name="Rounded Rectangle 28"/>
+          <p:cNvPr id="28" name="Rounded Rectangle 27"/>
           <p:cNvSpPr/>
           <p:nvPr/>
         </p:nvSpPr>
@@ -9058,7 +8607,7 @@
       </p:sp>
       <p:sp>
         <p:nvSpPr>
-          <p:cNvPr id="30" name="Rounded Rectangle 29"/>
+          <p:cNvPr id="29" name="Rounded Rectangle 28"/>
           <p:cNvSpPr/>
           <p:nvPr/>
         </p:nvSpPr>
@@ -9121,7 +8670,7 @@
       </p:sp>
       <p:sp>
         <p:nvSpPr>
-          <p:cNvPr id="31" name="TextBox 30"/>
+          <p:cNvPr id="30" name="TextBox 29"/>
           <p:cNvSpPr txBox="1"/>
           <p:nvPr/>
         </p:nvSpPr>
@@ -9167,7 +8716,7 @@
       </p:sp>
       <p:sp>
         <p:nvSpPr>
-          <p:cNvPr id="32" name="Rectangle 31"/>
+          <p:cNvPr id="31" name="Rectangle 30"/>
           <p:cNvSpPr/>
           <p:nvPr/>
         </p:nvSpPr>
@@ -9254,7 +8803,7 @@
       </p:sp>
       <p:sp>
         <p:nvSpPr>
-          <p:cNvPr id="33" name="Rectangle 32"/>
+          <p:cNvPr id="32" name="Rectangle 31"/>
           <p:cNvSpPr/>
           <p:nvPr/>
         </p:nvSpPr>
@@ -9341,7 +8890,7 @@
       </p:sp>
       <p:sp>
         <p:nvSpPr>
-          <p:cNvPr id="34" name="Rounded Rectangle 33"/>
+          <p:cNvPr id="33" name="Rounded Rectangle 32"/>
           <p:cNvSpPr/>
           <p:nvPr/>
         </p:nvSpPr>
@@ -9521,88 +9070,7 @@
       </p:cxnSp>
       <p:sp>
         <p:nvSpPr>
-          <p:cNvPr id="4" name="Rectangle 3"/>
-          <p:cNvSpPr/>
-          <p:nvPr/>
-        </p:nvSpPr>
-        <p:spPr>
-          <a:xfrm>
-            <a:off x="10058400" y="164592"/>
-            <a:ext cx="1737360" cy="603504"/>
-          </a:xfrm>
-          <a:prstGeom prst="rect">
-            <a:avLst/>
-          </a:prstGeom>
-          <a:solidFill>
-            <a:srgbClr val="1273C4"/>
-          </a:solidFill>
-          <a:ln>
-            <a:noFill/>
-          </a:ln>
-          <a:effectLst/>
-        </p:spPr>
-        <p:style>
-          <a:lnRef idx="1">
-            <a:schemeClr val="accent1"/>
-          </a:lnRef>
-          <a:fillRef idx="3">
-            <a:schemeClr val="accent1"/>
-          </a:fillRef>
-          <a:effectRef idx="2">
-            <a:schemeClr val="accent1"/>
-          </a:effectRef>
-          <a:fontRef idx="minor">
-            <a:schemeClr val="lt1"/>
-          </a:fontRef>
-        </p:style>
-        <p:txBody>
-          <a:bodyPr rtlCol="0" anchor="ctr" wrap="square" lIns="50800" rIns="50800" tIns="25400" bIns="25400"/>
-          <a:lstStyle/>
-          <a:p>
-            <a:pPr algn="ctr">
-              <a:spcBef>
-                <a:spcPts val="0"/>
-              </a:spcBef>
-              <a:spcAft>
-                <a:spcPts val="0"/>
-              </a:spcAft>
-            </a:pPr>
-            <a:r>
-              <a:rPr sz="1400" b="0">
-                <a:solidFill>
-                  <a:srgbClr val="FFFFFF"/>
-                </a:solidFill>
-                <a:latin typeface="NanumSquareOTF_ac ExtraBold"/>
-                <a:ea typeface="NanumSquareOTF_ac ExtraBold"/>
-              </a:rPr>
-              <a:t>김강호</a:t>
-            </a:r>
-          </a:p>
-          <a:p>
-            <a:pPr algn="ctr">
-              <a:spcBef>
-                <a:spcPts val="0"/>
-              </a:spcBef>
-              <a:spcAft>
-                <a:spcPts val="0"/>
-              </a:spcAft>
-            </a:pPr>
-            <a:r>
-              <a:rPr sz="1000" b="0">
-                <a:solidFill>
-                  <a:srgbClr val="FFFFFF"/>
-                </a:solidFill>
-                <a:latin typeface="NanumSquareOTF_ac"/>
-                <a:ea typeface="NanumSquareOTF_ac"/>
-              </a:rPr>
-              <a:t>Access Tech.팀</a:t>
-            </a:r>
-          </a:p>
-        </p:txBody>
-      </p:sp>
-      <p:sp>
-        <p:nvSpPr>
-          <p:cNvPr id="5" name="TextBox 4"/>
+          <p:cNvPr id="4" name="TextBox 3"/>
           <p:cNvSpPr txBox="1"/>
           <p:nvPr/>
         </p:nvSpPr>
@@ -9645,7 +9113,7 @@
       </p:sp>
       <p:sp>
         <p:nvSpPr>
-          <p:cNvPr id="6" name="Rounded Rectangle 5"/>
+          <p:cNvPr id="5" name="Rounded Rectangle 4"/>
           <p:cNvSpPr/>
           <p:nvPr/>
         </p:nvSpPr>
@@ -9693,7 +9161,7 @@
       </p:sp>
       <p:sp>
         <p:nvSpPr>
-          <p:cNvPr id="7" name="Rounded Rectangle 6"/>
+          <p:cNvPr id="6" name="Rounded Rectangle 5"/>
           <p:cNvSpPr/>
           <p:nvPr/>
         </p:nvSpPr>
@@ -9756,7 +9224,7 @@
       </p:sp>
       <p:sp>
         <p:nvSpPr>
-          <p:cNvPr id="8" name="TextBox 7"/>
+          <p:cNvPr id="7" name="TextBox 6"/>
           <p:cNvSpPr txBox="1"/>
           <p:nvPr/>
         </p:nvSpPr>
@@ -9802,7 +9270,7 @@
       </p:sp>
       <p:cxnSp>
         <p:nvCxnSpPr>
-          <p:cNvPr id="9" name="Connector 8"/>
+          <p:cNvPr id="8" name="Connector 7"/>
           <p:cNvCxnSpPr/>
           <p:nvPr/>
         </p:nvCxnSpPr>
@@ -9838,7 +9306,7 @@
       </p:cxnSp>
       <p:sp>
         <p:nvSpPr>
-          <p:cNvPr id="10" name="Rectangle 9"/>
+          <p:cNvPr id="9" name="Rectangle 8"/>
           <p:cNvSpPr/>
           <p:nvPr/>
         </p:nvSpPr>
@@ -9925,7 +9393,7 @@
       </p:sp>
       <p:sp>
         <p:nvSpPr>
-          <p:cNvPr id="11" name="Right Arrow 10"/>
+          <p:cNvPr id="10" name="Right Arrow 9"/>
           <p:cNvSpPr/>
           <p:nvPr/>
         </p:nvSpPr>
@@ -9969,7 +9437,7 @@
       </p:sp>
       <p:sp>
         <p:nvSpPr>
-          <p:cNvPr id="12" name="TextBox 11"/>
+          <p:cNvPr id="11" name="TextBox 10"/>
           <p:cNvSpPr txBox="1"/>
           <p:nvPr/>
         </p:nvSpPr>
@@ -10015,7 +9483,7 @@
       </p:sp>
       <p:sp>
         <p:nvSpPr>
-          <p:cNvPr id="13" name="Rectangle 12"/>
+          <p:cNvPr id="12" name="Rectangle 11"/>
           <p:cNvSpPr/>
           <p:nvPr/>
         </p:nvSpPr>
@@ -10082,7 +9550,7 @@
       </p:sp>
       <p:sp>
         <p:nvSpPr>
-          <p:cNvPr id="14" name="Rectangle 13"/>
+          <p:cNvPr id="13" name="Rectangle 12"/>
           <p:cNvSpPr/>
           <p:nvPr/>
         </p:nvSpPr>
@@ -10149,7 +9617,7 @@
       </p:sp>
       <p:sp>
         <p:nvSpPr>
-          <p:cNvPr id="15" name="Rectangle 14"/>
+          <p:cNvPr id="14" name="Rectangle 13"/>
           <p:cNvSpPr/>
           <p:nvPr/>
         </p:nvSpPr>
@@ -10213,7 +9681,7 @@
       </p:sp>
       <p:sp>
         <p:nvSpPr>
-          <p:cNvPr id="16" name="Up Arrow 15"/>
+          <p:cNvPr id="15" name="Up Arrow 14"/>
           <p:cNvSpPr/>
           <p:nvPr/>
         </p:nvSpPr>
@@ -10257,7 +9725,7 @@
       </p:sp>
       <p:sp>
         <p:nvSpPr>
-          <p:cNvPr id="17" name="TextBox 16"/>
+          <p:cNvPr id="16" name="TextBox 15"/>
           <p:cNvSpPr txBox="1"/>
           <p:nvPr/>
         </p:nvSpPr>
@@ -10303,7 +9771,7 @@
       </p:sp>
       <p:sp>
         <p:nvSpPr>
-          <p:cNvPr id="18" name="Rectangle 17"/>
+          <p:cNvPr id="17" name="Rectangle 16"/>
           <p:cNvSpPr/>
           <p:nvPr/>
         </p:nvSpPr>
@@ -10364,7 +9832,7 @@
       </p:sp>
       <p:sp>
         <p:nvSpPr>
-          <p:cNvPr id="19" name="Rectangle 18"/>
+          <p:cNvPr id="18" name="Rectangle 17"/>
           <p:cNvSpPr/>
           <p:nvPr/>
         </p:nvSpPr>
@@ -10428,7 +9896,7 @@
       </p:sp>
       <p:sp>
         <p:nvSpPr>
-          <p:cNvPr id="20" name="TextBox 19"/>
+          <p:cNvPr id="19" name="TextBox 18"/>
           <p:cNvSpPr txBox="1"/>
           <p:nvPr/>
         </p:nvSpPr>
@@ -10474,7 +9942,7 @@
       </p:sp>
       <p:sp>
         <p:nvSpPr>
-          <p:cNvPr id="21" name="Rectangle 20"/>
+          <p:cNvPr id="20" name="Rectangle 19"/>
           <p:cNvSpPr/>
           <p:nvPr/>
         </p:nvSpPr>
@@ -10538,7 +10006,7 @@
       </p:sp>
       <p:sp>
         <p:nvSpPr>
-          <p:cNvPr id="22" name="TextBox 21"/>
+          <p:cNvPr id="21" name="TextBox 20"/>
           <p:cNvSpPr txBox="1"/>
           <p:nvPr/>
         </p:nvSpPr>
@@ -10584,7 +10052,7 @@
       </p:sp>
       <p:sp>
         <p:nvSpPr>
-          <p:cNvPr id="23" name="Rounded Rectangle 22"/>
+          <p:cNvPr id="22" name="Rounded Rectangle 21"/>
           <p:cNvSpPr/>
           <p:nvPr/>
         </p:nvSpPr>
@@ -10632,7 +10100,7 @@
       </p:sp>
       <p:sp>
         <p:nvSpPr>
-          <p:cNvPr id="24" name="Rounded Rectangle 23"/>
+          <p:cNvPr id="23" name="Rounded Rectangle 22"/>
           <p:cNvSpPr/>
           <p:nvPr/>
         </p:nvSpPr>
@@ -10695,7 +10163,7 @@
       </p:sp>
       <p:sp>
         <p:nvSpPr>
-          <p:cNvPr id="25" name="Rectangle 24"/>
+          <p:cNvPr id="24" name="Rectangle 23"/>
           <p:cNvSpPr/>
           <p:nvPr/>
         </p:nvSpPr>
@@ -10760,7 +10228,7 @@
       </p:sp>
       <p:sp>
         <p:nvSpPr>
-          <p:cNvPr id="26" name="TextBox 25"/>
+          <p:cNvPr id="25" name="TextBox 24"/>
           <p:cNvSpPr txBox="1"/>
           <p:nvPr/>
         </p:nvSpPr>
@@ -10829,7 +10297,7 @@
       </p:sp>
       <p:sp>
         <p:nvSpPr>
-          <p:cNvPr id="27" name="Rectangle 26"/>
+          <p:cNvPr id="26" name="Rectangle 25"/>
           <p:cNvSpPr/>
           <p:nvPr/>
         </p:nvSpPr>
@@ -10894,7 +10362,7 @@
       </p:sp>
       <p:sp>
         <p:nvSpPr>
-          <p:cNvPr id="28" name="TextBox 27"/>
+          <p:cNvPr id="27" name="TextBox 26"/>
           <p:cNvSpPr txBox="1"/>
           <p:nvPr/>
         </p:nvSpPr>
@@ -10963,7 +10431,7 @@
       </p:sp>
       <p:sp>
         <p:nvSpPr>
-          <p:cNvPr id="29" name="Rounded Rectangle 28"/>
+          <p:cNvPr id="28" name="Rounded Rectangle 27"/>
           <p:cNvSpPr/>
           <p:nvPr/>
         </p:nvSpPr>
@@ -11011,7 +10479,7 @@
       </p:sp>
       <p:sp>
         <p:nvSpPr>
-          <p:cNvPr id="30" name="Rounded Rectangle 29"/>
+          <p:cNvPr id="29" name="Rounded Rectangle 28"/>
           <p:cNvSpPr/>
           <p:nvPr/>
         </p:nvSpPr>
@@ -11074,7 +10542,7 @@
       </p:sp>
       <p:sp>
         <p:nvSpPr>
-          <p:cNvPr id="31" name="TextBox 30"/>
+          <p:cNvPr id="30" name="TextBox 29"/>
           <p:cNvSpPr txBox="1"/>
           <p:nvPr/>
         </p:nvSpPr>
@@ -11120,7 +10588,7 @@
       </p:sp>
       <p:sp>
         <p:nvSpPr>
-          <p:cNvPr id="32" name="TextBox 31"/>
+          <p:cNvPr id="31" name="TextBox 30"/>
           <p:cNvSpPr txBox="1"/>
           <p:nvPr/>
         </p:nvSpPr>
@@ -11166,7 +10634,7 @@
       </p:sp>
       <p:sp>
         <p:nvSpPr>
-          <p:cNvPr id="33" name="Rectangle 32"/>
+          <p:cNvPr id="32" name="Rectangle 31"/>
           <p:cNvSpPr/>
           <p:nvPr/>
         </p:nvSpPr>
@@ -11230,7 +10698,7 @@
       </p:sp>
       <p:sp>
         <p:nvSpPr>
-          <p:cNvPr id="34" name="Rectangle 33"/>
+          <p:cNvPr id="33" name="Rectangle 32"/>
           <p:cNvSpPr/>
           <p:nvPr/>
         </p:nvSpPr>
@@ -11294,7 +10762,7 @@
       </p:sp>
       <p:sp>
         <p:nvSpPr>
-          <p:cNvPr id="35" name="Pentagon 34"/>
+          <p:cNvPr id="34" name="Pentagon 33"/>
           <p:cNvSpPr/>
           <p:nvPr/>
         </p:nvSpPr>
@@ -11355,7 +10823,7 @@
       </p:sp>
       <p:sp>
         <p:nvSpPr>
-          <p:cNvPr id="36" name="Rectangle 35"/>
+          <p:cNvPr id="35" name="Rectangle 34"/>
           <p:cNvSpPr/>
           <p:nvPr/>
         </p:nvSpPr>
@@ -11419,7 +10887,7 @@
       </p:sp>
       <p:sp>
         <p:nvSpPr>
-          <p:cNvPr id="37" name="Pentagon 36"/>
+          <p:cNvPr id="36" name="Pentagon 35"/>
           <p:cNvSpPr/>
           <p:nvPr/>
         </p:nvSpPr>
@@ -11480,7 +10948,7 @@
       </p:sp>
       <p:sp>
         <p:nvSpPr>
-          <p:cNvPr id="38" name="Rounded Rectangle 37"/>
+          <p:cNvPr id="37" name="Rounded Rectangle 36"/>
           <p:cNvSpPr/>
           <p:nvPr/>
         </p:nvSpPr>
@@ -11660,88 +11128,7 @@
       </p:cxnSp>
       <p:sp>
         <p:nvSpPr>
-          <p:cNvPr id="4" name="Rectangle 3"/>
-          <p:cNvSpPr/>
-          <p:nvPr/>
-        </p:nvSpPr>
-        <p:spPr>
-          <a:xfrm>
-            <a:off x="10058400" y="164592"/>
-            <a:ext cx="1737360" cy="603504"/>
-          </a:xfrm>
-          <a:prstGeom prst="rect">
-            <a:avLst/>
-          </a:prstGeom>
-          <a:solidFill>
-            <a:srgbClr val="1273C4"/>
-          </a:solidFill>
-          <a:ln>
-            <a:noFill/>
-          </a:ln>
-          <a:effectLst/>
-        </p:spPr>
-        <p:style>
-          <a:lnRef idx="1">
-            <a:schemeClr val="accent1"/>
-          </a:lnRef>
-          <a:fillRef idx="3">
-            <a:schemeClr val="accent1"/>
-          </a:fillRef>
-          <a:effectRef idx="2">
-            <a:schemeClr val="accent1"/>
-          </a:effectRef>
-          <a:fontRef idx="minor">
-            <a:schemeClr val="lt1"/>
-          </a:fontRef>
-        </p:style>
-        <p:txBody>
-          <a:bodyPr rtlCol="0" anchor="ctr" wrap="square" lIns="50800" rIns="50800" tIns="25400" bIns="25400"/>
-          <a:lstStyle/>
-          <a:p>
-            <a:pPr algn="ctr">
-              <a:spcBef>
-                <a:spcPts val="0"/>
-              </a:spcBef>
-              <a:spcAft>
-                <a:spcPts val="0"/>
-              </a:spcAft>
-            </a:pPr>
-            <a:r>
-              <a:rPr sz="1400" b="0">
-                <a:solidFill>
-                  <a:srgbClr val="FFFFFF"/>
-                </a:solidFill>
-                <a:latin typeface="NanumSquareOTF_ac ExtraBold"/>
-                <a:ea typeface="NanumSquareOTF_ac ExtraBold"/>
-              </a:rPr>
-              <a:t>[발표자]</a:t>
-            </a:r>
-          </a:p>
-          <a:p>
-            <a:pPr algn="ctr">
-              <a:spcBef>
-                <a:spcPts val="0"/>
-              </a:spcBef>
-              <a:spcAft>
-                <a:spcPts val="0"/>
-              </a:spcAft>
-            </a:pPr>
-            <a:r>
-              <a:rPr sz="1000" b="0">
-                <a:solidFill>
-                  <a:srgbClr val="FFFFFF"/>
-                </a:solidFill>
-                <a:latin typeface="NanumSquareOTF_ac"/>
-                <a:ea typeface="NanumSquareOTF_ac"/>
-              </a:rPr>
-              <a:t>[소속 팀]</a:t>
-            </a:r>
-          </a:p>
-        </p:txBody>
-      </p:sp>
-      <p:sp>
-        <p:nvSpPr>
-          <p:cNvPr id="5" name="TextBox 4"/>
+          <p:cNvPr id="4" name="TextBox 3"/>
           <p:cNvSpPr txBox="1"/>
           <p:nvPr/>
         </p:nvSpPr>
@@ -11784,7 +11171,7 @@
       </p:sp>
       <p:sp>
         <p:nvSpPr>
-          <p:cNvPr id="6" name="Rounded Rectangle 5"/>
+          <p:cNvPr id="5" name="Rounded Rectangle 4"/>
           <p:cNvSpPr/>
           <p:nvPr/>
         </p:nvSpPr>
@@ -11832,7 +11219,7 @@
       </p:sp>
       <p:sp>
         <p:nvSpPr>
-          <p:cNvPr id="7" name="Rounded Rectangle 6"/>
+          <p:cNvPr id="6" name="Rounded Rectangle 5"/>
           <p:cNvSpPr/>
           <p:nvPr/>
         </p:nvSpPr>
@@ -11895,7 +11282,7 @@
       </p:sp>
       <p:sp>
         <p:nvSpPr>
-          <p:cNvPr id="8" name="TextBox 7"/>
+          <p:cNvPr id="7" name="TextBox 6"/>
           <p:cNvSpPr txBox="1"/>
           <p:nvPr/>
         </p:nvSpPr>
@@ -11941,7 +11328,7 @@
       </p:sp>
       <p:cxnSp>
         <p:nvCxnSpPr>
-          <p:cNvPr id="9" name="Connector 8"/>
+          <p:cNvPr id="8" name="Connector 7"/>
           <p:cNvCxnSpPr/>
           <p:nvPr/>
         </p:nvCxnSpPr>
@@ -11977,7 +11364,7 @@
       </p:cxnSp>
       <p:sp>
         <p:nvSpPr>
-          <p:cNvPr id="10" name="Rounded Rectangle 9"/>
+          <p:cNvPr id="9" name="Rounded Rectangle 8"/>
           <p:cNvSpPr/>
           <p:nvPr/>
         </p:nvSpPr>
@@ -12025,7 +11412,7 @@
       </p:sp>
       <p:sp>
         <p:nvSpPr>
-          <p:cNvPr id="11" name="Rounded Rectangle 10"/>
+          <p:cNvPr id="10" name="Rounded Rectangle 9"/>
           <p:cNvSpPr/>
           <p:nvPr/>
         </p:nvSpPr>
@@ -12088,7 +11475,7 @@
       </p:sp>
       <p:sp>
         <p:nvSpPr>
-          <p:cNvPr id="12" name="Rounded Rectangle 11"/>
+          <p:cNvPr id="11" name="Rounded Rectangle 10"/>
           <p:cNvSpPr/>
           <p:nvPr/>
         </p:nvSpPr>
@@ -12136,7 +11523,7 @@
       </p:sp>
       <p:sp>
         <p:nvSpPr>
-          <p:cNvPr id="13" name="Rounded Rectangle 12"/>
+          <p:cNvPr id="12" name="Rounded Rectangle 11"/>
           <p:cNvSpPr/>
           <p:nvPr/>
         </p:nvSpPr>
@@ -12199,7 +11586,7 @@
       </p:sp>
       <p:sp>
         <p:nvSpPr>
-          <p:cNvPr id="14" name="Rounded Rectangle 13"/>
+          <p:cNvPr id="13" name="Rounded Rectangle 12"/>
           <p:cNvSpPr/>
           <p:nvPr/>
         </p:nvSpPr>
@@ -12379,88 +11766,7 @@
       </p:cxnSp>
       <p:sp>
         <p:nvSpPr>
-          <p:cNvPr id="4" name="Rectangle 3"/>
-          <p:cNvSpPr/>
-          <p:nvPr/>
-        </p:nvSpPr>
-        <p:spPr>
-          <a:xfrm>
-            <a:off x="10058400" y="164592"/>
-            <a:ext cx="1737360" cy="603504"/>
-          </a:xfrm>
-          <a:prstGeom prst="rect">
-            <a:avLst/>
-          </a:prstGeom>
-          <a:solidFill>
-            <a:srgbClr val="1273C4"/>
-          </a:solidFill>
-          <a:ln>
-            <a:noFill/>
-          </a:ln>
-          <a:effectLst/>
-        </p:spPr>
-        <p:style>
-          <a:lnRef idx="1">
-            <a:schemeClr val="accent1"/>
-          </a:lnRef>
-          <a:fillRef idx="3">
-            <a:schemeClr val="accent1"/>
-          </a:fillRef>
-          <a:effectRef idx="2">
-            <a:schemeClr val="accent1"/>
-          </a:effectRef>
-          <a:fontRef idx="minor">
-            <a:schemeClr val="lt1"/>
-          </a:fontRef>
-        </p:style>
-        <p:txBody>
-          <a:bodyPr rtlCol="0" anchor="ctr" wrap="square" lIns="50800" rIns="50800" tIns="25400" bIns="25400"/>
-          <a:lstStyle/>
-          <a:p>
-            <a:pPr algn="ctr">
-              <a:spcBef>
-                <a:spcPts val="0"/>
-              </a:spcBef>
-              <a:spcAft>
-                <a:spcPts val="0"/>
-              </a:spcAft>
-            </a:pPr>
-            <a:r>
-              <a:rPr sz="1400" b="0">
-                <a:solidFill>
-                  <a:srgbClr val="FFFFFF"/>
-                </a:solidFill>
-                <a:latin typeface="NanumSquareOTF_ac ExtraBold"/>
-                <a:ea typeface="NanumSquareOTF_ac ExtraBold"/>
-              </a:rPr>
-              <a:t>[발표자]</a:t>
-            </a:r>
-          </a:p>
-          <a:p>
-            <a:pPr algn="ctr">
-              <a:spcBef>
-                <a:spcPts val="0"/>
-              </a:spcBef>
-              <a:spcAft>
-                <a:spcPts val="0"/>
-              </a:spcAft>
-            </a:pPr>
-            <a:r>
-              <a:rPr sz="1000" b="0">
-                <a:solidFill>
-                  <a:srgbClr val="FFFFFF"/>
-                </a:solidFill>
-                <a:latin typeface="NanumSquareOTF_ac"/>
-                <a:ea typeface="NanumSquareOTF_ac"/>
-              </a:rPr>
-              <a:t>[소속 팀]</a:t>
-            </a:r>
-          </a:p>
-        </p:txBody>
-      </p:sp>
-      <p:sp>
-        <p:nvSpPr>
-          <p:cNvPr id="5" name="TextBox 4"/>
+          <p:cNvPr id="4" name="TextBox 3"/>
           <p:cNvSpPr txBox="1"/>
           <p:nvPr/>
         </p:nvSpPr>
@@ -12503,7 +11809,7 @@
       </p:sp>
       <p:sp>
         <p:nvSpPr>
-          <p:cNvPr id="6" name="Rounded Rectangle 5"/>
+          <p:cNvPr id="5" name="Rounded Rectangle 4"/>
           <p:cNvSpPr/>
           <p:nvPr/>
         </p:nvSpPr>
@@ -12551,7 +11857,7 @@
       </p:sp>
       <p:sp>
         <p:nvSpPr>
-          <p:cNvPr id="7" name="Rounded Rectangle 6"/>
+          <p:cNvPr id="6" name="Rounded Rectangle 5"/>
           <p:cNvSpPr/>
           <p:nvPr/>
         </p:nvSpPr>
@@ -12614,7 +11920,7 @@
       </p:sp>
       <p:sp>
         <p:nvSpPr>
-          <p:cNvPr id="8" name="Rounded Rectangle 7"/>
+          <p:cNvPr id="7" name="Rounded Rectangle 6"/>
           <p:cNvSpPr/>
           <p:nvPr/>
         </p:nvSpPr>
@@ -12662,7 +11968,7 @@
       </p:sp>
       <p:sp>
         <p:nvSpPr>
-          <p:cNvPr id="9" name="Rounded Rectangle 8"/>
+          <p:cNvPr id="8" name="Rounded Rectangle 7"/>
           <p:cNvSpPr/>
           <p:nvPr/>
         </p:nvSpPr>
@@ -12725,7 +12031,7 @@
       </p:sp>
       <p:sp>
         <p:nvSpPr>
-          <p:cNvPr id="10" name="Rounded Rectangle 9"/>
+          <p:cNvPr id="9" name="Rounded Rectangle 8"/>
           <p:cNvSpPr/>
           <p:nvPr/>
         </p:nvSpPr>

</xml_diff>